<commit_message>
feat(programme): le kiosque 10 devient « Mini-Série TESTY »
Une seule ligne change dans la page servie. Tout le reste suit : les dix
affiches A3, les écrans, la présentation, la diapo en main, la variante
programme-kiosques et les fiches de scène sont régénérés — ils lisent tous le
titre dans la page.

Effet de bord à noter plutôt qu'à taire : « libre service » disparaît du titre.
La page ne prend donc plus parti dans la contradiction du § 16 du conducteur,
où le fichier source annonce un visionnage libre et le conducteur du 10/09 une
diffusion présentée de l'épisode 4. La question reste ouverte, l'alerte reste
sur la carte de pitch du kiosque 10.

Co-Authored-By: Claude Opus 5 <noreply@anthropic.com>
Claude-Session: https://claude.ai/code/session_01Pwjz3VzeEknRuHTVSBE4Pa
</commit_message>
<xml_diff>
--- a/outils/fiches/fiches-animateurs.pptx
+++ b/outils/fiches/fiches-animateurs.pptx
@@ -20402,7 +20402,7 @@
         <p:spPr>
           <a:xfrm>
             <a:off x="687600" y="2392906"/>
-            <a:ext cx="1839023" cy="151200"/>
+            <a:ext cx="1770912" cy="151200"/>
           </a:xfrm>
           <a:prstGeom prst="rect">
             <a:avLst/>
@@ -20440,7 +20440,7 @@
         </p:nvSpPr>
         <p:spPr>
           <a:xfrm>
-            <a:off x="2584224" y="2392906"/>
+            <a:off x="2516112" y="2392906"/>
             <a:ext cx="990719" cy="151200"/>
           </a:xfrm>
           <a:prstGeom prst="rect">
@@ -20479,7 +20479,7 @@
         </p:nvSpPr>
         <p:spPr>
           <a:xfrm>
-            <a:off x="3632543" y="2392906"/>
+            <a:off x="3564431" y="2392906"/>
             <a:ext cx="1176480" cy="151200"/>
           </a:xfrm>
           <a:prstGeom prst="rect">
@@ -20593,7 +20593,7 @@
         <p:spPr>
           <a:xfrm>
             <a:off x="687600" y="2580106"/>
-            <a:ext cx="1839023" cy="198000"/>
+            <a:ext cx="1770912" cy="198000"/>
           </a:xfrm>
           <a:prstGeom prst="rect">
             <a:avLst/>
@@ -20631,7 +20631,7 @@
         </p:nvSpPr>
         <p:spPr>
           <a:xfrm>
-            <a:off x="2584224" y="2580106"/>
+            <a:off x="2516112" y="2580106"/>
             <a:ext cx="990719" cy="198000"/>
           </a:xfrm>
           <a:prstGeom prst="rect">
@@ -20670,7 +20670,7 @@
         </p:nvSpPr>
         <p:spPr>
           <a:xfrm>
-            <a:off x="3632543" y="2580106"/>
+            <a:off x="3564431" y="2580106"/>
             <a:ext cx="1176480" cy="198000"/>
           </a:xfrm>
           <a:prstGeom prst="rect">
@@ -20749,7 +20749,7 @@
         <p:spPr>
           <a:xfrm>
             <a:off x="687600" y="2817706"/>
-            <a:ext cx="1839023" cy="198000"/>
+            <a:ext cx="1770912" cy="198000"/>
           </a:xfrm>
           <a:prstGeom prst="rect">
             <a:avLst/>
@@ -20787,7 +20787,7 @@
         </p:nvSpPr>
         <p:spPr>
           <a:xfrm>
-            <a:off x="2584224" y="2817706"/>
+            <a:off x="2516112" y="2817706"/>
             <a:ext cx="990719" cy="198000"/>
           </a:xfrm>
           <a:prstGeom prst="rect">
@@ -20826,7 +20826,7 @@
         </p:nvSpPr>
         <p:spPr>
           <a:xfrm>
-            <a:off x="3632543" y="2817706"/>
+            <a:off x="3564431" y="2817706"/>
             <a:ext cx="1176480" cy="198000"/>
           </a:xfrm>
           <a:prstGeom prst="rect">
@@ -20905,7 +20905,7 @@
         <p:spPr>
           <a:xfrm>
             <a:off x="687600" y="3055306"/>
-            <a:ext cx="1839023" cy="198000"/>
+            <a:ext cx="1770912" cy="198000"/>
           </a:xfrm>
           <a:prstGeom prst="rect">
             <a:avLst/>
@@ -20943,7 +20943,7 @@
         </p:nvSpPr>
         <p:spPr>
           <a:xfrm>
-            <a:off x="2584224" y="3055306"/>
+            <a:off x="2516112" y="3055306"/>
             <a:ext cx="990719" cy="198000"/>
           </a:xfrm>
           <a:prstGeom prst="rect">
@@ -20982,7 +20982,7 @@
         </p:nvSpPr>
         <p:spPr>
           <a:xfrm>
-            <a:off x="3632543" y="3055306"/>
+            <a:off x="3564431" y="3055306"/>
             <a:ext cx="1176480" cy="198000"/>
           </a:xfrm>
           <a:prstGeom prst="rect">
@@ -21061,7 +21061,7 @@
         <p:spPr>
           <a:xfrm>
             <a:off x="687600" y="3292906"/>
-            <a:ext cx="1839023" cy="198000"/>
+            <a:ext cx="1770912" cy="198000"/>
           </a:xfrm>
           <a:prstGeom prst="rect">
             <a:avLst/>
@@ -21099,7 +21099,7 @@
         </p:nvSpPr>
         <p:spPr>
           <a:xfrm>
-            <a:off x="2584224" y="3292906"/>
+            <a:off x="2516112" y="3292906"/>
             <a:ext cx="990719" cy="198000"/>
           </a:xfrm>
           <a:prstGeom prst="rect">
@@ -21138,7 +21138,7 @@
         </p:nvSpPr>
         <p:spPr>
           <a:xfrm>
-            <a:off x="3632543" y="3292906"/>
+            <a:off x="3564431" y="3292906"/>
             <a:ext cx="1176480" cy="198000"/>
           </a:xfrm>
           <a:prstGeom prst="rect">
@@ -21217,7 +21217,7 @@
         <p:spPr>
           <a:xfrm>
             <a:off x="687600" y="3530506"/>
-            <a:ext cx="1839023" cy="198000"/>
+            <a:ext cx="1770912" cy="198000"/>
           </a:xfrm>
           <a:prstGeom prst="rect">
             <a:avLst/>
@@ -21255,7 +21255,7 @@
         </p:nvSpPr>
         <p:spPr>
           <a:xfrm>
-            <a:off x="2584224" y="3530506"/>
+            <a:off x="2516112" y="3530506"/>
             <a:ext cx="990719" cy="198000"/>
           </a:xfrm>
           <a:prstGeom prst="rect">
@@ -21294,7 +21294,7 @@
         </p:nvSpPr>
         <p:spPr>
           <a:xfrm>
-            <a:off x="3632543" y="3530506"/>
+            <a:off x="3564431" y="3530506"/>
             <a:ext cx="1176480" cy="198000"/>
           </a:xfrm>
           <a:prstGeom prst="rect">
@@ -21373,7 +21373,7 @@
         <p:spPr>
           <a:xfrm>
             <a:off x="687600" y="3768106"/>
-            <a:ext cx="1839023" cy="198000"/>
+            <a:ext cx="1770912" cy="198000"/>
           </a:xfrm>
           <a:prstGeom prst="rect">
             <a:avLst/>
@@ -21411,7 +21411,7 @@
         </p:nvSpPr>
         <p:spPr>
           <a:xfrm>
-            <a:off x="2584224" y="3768106"/>
+            <a:off x="2516112" y="3768106"/>
             <a:ext cx="990719" cy="198000"/>
           </a:xfrm>
           <a:prstGeom prst="rect">
@@ -21450,7 +21450,7 @@
         </p:nvSpPr>
         <p:spPr>
           <a:xfrm>
-            <a:off x="3632543" y="3768106"/>
+            <a:off x="3564431" y="3768106"/>
             <a:ext cx="1176480" cy="198000"/>
           </a:xfrm>
           <a:prstGeom prst="rect">
@@ -21529,7 +21529,7 @@
         <p:spPr>
           <a:xfrm>
             <a:off x="687600" y="4005706"/>
-            <a:ext cx="1839023" cy="198000"/>
+            <a:ext cx="1770912" cy="198000"/>
           </a:xfrm>
           <a:prstGeom prst="rect">
             <a:avLst/>
@@ -21567,7 +21567,7 @@
         </p:nvSpPr>
         <p:spPr>
           <a:xfrm>
-            <a:off x="2584224" y="4005706"/>
+            <a:off x="2516112" y="4005706"/>
             <a:ext cx="990719" cy="198000"/>
           </a:xfrm>
           <a:prstGeom prst="rect">
@@ -21606,7 +21606,7 @@
         </p:nvSpPr>
         <p:spPr>
           <a:xfrm>
-            <a:off x="3632543" y="4005706"/>
+            <a:off x="3564431" y="4005706"/>
             <a:ext cx="1176480" cy="198000"/>
           </a:xfrm>
           <a:prstGeom prst="rect">
@@ -21685,7 +21685,7 @@
         <p:spPr>
           <a:xfrm>
             <a:off x="687600" y="4243306"/>
-            <a:ext cx="1839023" cy="198000"/>
+            <a:ext cx="1770912" cy="198000"/>
           </a:xfrm>
           <a:prstGeom prst="rect">
             <a:avLst/>
@@ -21723,7 +21723,7 @@
         </p:nvSpPr>
         <p:spPr>
           <a:xfrm>
-            <a:off x="2584224" y="4243306"/>
+            <a:off x="2516112" y="4243306"/>
             <a:ext cx="990719" cy="198000"/>
           </a:xfrm>
           <a:prstGeom prst="rect">
@@ -21762,7 +21762,7 @@
         </p:nvSpPr>
         <p:spPr>
           <a:xfrm>
-            <a:off x="3632543" y="4243306"/>
+            <a:off x="3564431" y="4243306"/>
             <a:ext cx="1176480" cy="198000"/>
           </a:xfrm>
           <a:prstGeom prst="rect">
@@ -21841,7 +21841,7 @@
         <p:spPr>
           <a:xfrm>
             <a:off x="687600" y="4480906"/>
-            <a:ext cx="1839023" cy="198000"/>
+            <a:ext cx="1770912" cy="198000"/>
           </a:xfrm>
           <a:prstGeom prst="rect">
             <a:avLst/>
@@ -21879,7 +21879,7 @@
         </p:nvSpPr>
         <p:spPr>
           <a:xfrm>
-            <a:off x="2584224" y="4480906"/>
+            <a:off x="2516112" y="4480906"/>
             <a:ext cx="990719" cy="198000"/>
           </a:xfrm>
           <a:prstGeom prst="rect">
@@ -21918,7 +21918,7 @@
         </p:nvSpPr>
         <p:spPr>
           <a:xfrm>
-            <a:off x="3632543" y="4480906"/>
+            <a:off x="3564431" y="4480906"/>
             <a:ext cx="1176480" cy="198000"/>
           </a:xfrm>
           <a:prstGeom prst="rect">
@@ -21997,7 +21997,7 @@
         <p:spPr>
           <a:xfrm>
             <a:off x="687600" y="4718506"/>
-            <a:ext cx="1839023" cy="198000"/>
+            <a:ext cx="1770912" cy="198000"/>
           </a:xfrm>
           <a:prstGeom prst="rect">
             <a:avLst/>
@@ -22022,7 +22022,7 @@
                 </a:solidFill>
                 <a:latin typeface="Barlow"/>
               </a:rPr>
-              <a:t>Vidéo TESTY — libre service</a:t>
+              <a:t>Mini-Série TESTY</a:t>
             </a:r>
           </a:p>
         </p:txBody>
@@ -22035,7 +22035,7 @@
         </p:nvSpPr>
         <p:spPr>
           <a:xfrm>
-            <a:off x="2584224" y="4718506"/>
+            <a:off x="2516112" y="4718506"/>
             <a:ext cx="990719" cy="198000"/>
           </a:xfrm>
           <a:prstGeom prst="rect">
@@ -22074,7 +22074,7 @@
         </p:nvSpPr>
         <p:spPr>
           <a:xfrm>
-            <a:off x="3632543" y="4718506"/>
+            <a:off x="3564431" y="4718506"/>
             <a:ext cx="1176480" cy="198000"/>
           </a:xfrm>
           <a:prstGeom prst="rect">
@@ -27561,7 +27561,7 @@
                 </a:solidFill>
                 <a:latin typeface="Barlow Condensed"/>
               </a:rPr>
-              <a:t>Vidéo TESTY — libre service</a:t>
+              <a:t>Mini-Série TESTY</a:t>
             </a:r>
           </a:p>
         </p:txBody>
@@ -27677,7 +27677,7 @@
                 </a:solidFill>
                 <a:latin typeface="Barlow"/>
               </a:rPr>
-              <a:t>« Libre service » selon la page ; diffusion présentée de l’épisode 4 selon le conducteur du 10/09. À trancher avant de le dire.</a:t>
+              <a:t>Le fichier source finit par « visionnage en libre service » ; le conducteur du 10/09 décrit une diffusion présentée de l’épisode 4. À trancher avant de le dire.</a:t>
             </a:r>
           </a:p>
         </p:txBody>
@@ -34169,7 +34169,7 @@
         <p:spPr>
           <a:xfrm>
             <a:off x="687600" y="2585691"/>
-            <a:ext cx="1839023" cy="151200"/>
+            <a:ext cx="1770912" cy="151200"/>
           </a:xfrm>
           <a:prstGeom prst="rect">
             <a:avLst/>
@@ -34207,7 +34207,7 @@
         </p:nvSpPr>
         <p:spPr>
           <a:xfrm>
-            <a:off x="2584224" y="2585691"/>
+            <a:off x="2516112" y="2585691"/>
             <a:ext cx="990719" cy="151200"/>
           </a:xfrm>
           <a:prstGeom prst="rect">
@@ -34246,7 +34246,7 @@
         </p:nvSpPr>
         <p:spPr>
           <a:xfrm>
-            <a:off x="3632543" y="2585691"/>
+            <a:off x="3564431" y="2585691"/>
             <a:ext cx="1176480" cy="151200"/>
           </a:xfrm>
           <a:prstGeom prst="rect">
@@ -34360,7 +34360,7 @@
         <p:spPr>
           <a:xfrm>
             <a:off x="687600" y="2772891"/>
-            <a:ext cx="1839023" cy="198000"/>
+            <a:ext cx="1770912" cy="198000"/>
           </a:xfrm>
           <a:prstGeom prst="rect">
             <a:avLst/>
@@ -34398,7 +34398,7 @@
         </p:nvSpPr>
         <p:spPr>
           <a:xfrm>
-            <a:off x="2584224" y="2772891"/>
+            <a:off x="2516112" y="2772891"/>
             <a:ext cx="990719" cy="198000"/>
           </a:xfrm>
           <a:prstGeom prst="rect">
@@ -34437,7 +34437,7 @@
         </p:nvSpPr>
         <p:spPr>
           <a:xfrm>
-            <a:off x="3632543" y="2772891"/>
+            <a:off x="3564431" y="2772891"/>
             <a:ext cx="1176480" cy="198000"/>
           </a:xfrm>
           <a:prstGeom prst="rect">
@@ -34516,7 +34516,7 @@
         <p:spPr>
           <a:xfrm>
             <a:off x="687600" y="3010491"/>
-            <a:ext cx="1839023" cy="198000"/>
+            <a:ext cx="1770912" cy="198000"/>
           </a:xfrm>
           <a:prstGeom prst="rect">
             <a:avLst/>
@@ -34554,7 +34554,7 @@
         </p:nvSpPr>
         <p:spPr>
           <a:xfrm>
-            <a:off x="2584224" y="3010491"/>
+            <a:off x="2516112" y="3010491"/>
             <a:ext cx="990719" cy="198000"/>
           </a:xfrm>
           <a:prstGeom prst="rect">
@@ -34593,7 +34593,7 @@
         </p:nvSpPr>
         <p:spPr>
           <a:xfrm>
-            <a:off x="3632543" y="3010491"/>
+            <a:off x="3564431" y="3010491"/>
             <a:ext cx="1176480" cy="198000"/>
           </a:xfrm>
           <a:prstGeom prst="rect">
@@ -34672,7 +34672,7 @@
         <p:spPr>
           <a:xfrm>
             <a:off x="687600" y="3248091"/>
-            <a:ext cx="1839023" cy="198000"/>
+            <a:ext cx="1770912" cy="198000"/>
           </a:xfrm>
           <a:prstGeom prst="rect">
             <a:avLst/>
@@ -34710,7 +34710,7 @@
         </p:nvSpPr>
         <p:spPr>
           <a:xfrm>
-            <a:off x="2584224" y="3248091"/>
+            <a:off x="2516112" y="3248091"/>
             <a:ext cx="990719" cy="198000"/>
           </a:xfrm>
           <a:prstGeom prst="rect">
@@ -34749,7 +34749,7 @@
         </p:nvSpPr>
         <p:spPr>
           <a:xfrm>
-            <a:off x="3632543" y="3248091"/>
+            <a:off x="3564431" y="3248091"/>
             <a:ext cx="1176480" cy="198000"/>
           </a:xfrm>
           <a:prstGeom prst="rect">
@@ -34828,7 +34828,7 @@
         <p:spPr>
           <a:xfrm>
             <a:off x="687600" y="3485691"/>
-            <a:ext cx="1839023" cy="198000"/>
+            <a:ext cx="1770912" cy="198000"/>
           </a:xfrm>
           <a:prstGeom prst="rect">
             <a:avLst/>
@@ -34866,7 +34866,7 @@
         </p:nvSpPr>
         <p:spPr>
           <a:xfrm>
-            <a:off x="2584224" y="3485691"/>
+            <a:off x="2516112" y="3485691"/>
             <a:ext cx="990719" cy="198000"/>
           </a:xfrm>
           <a:prstGeom prst="rect">
@@ -34905,7 +34905,7 @@
         </p:nvSpPr>
         <p:spPr>
           <a:xfrm>
-            <a:off x="3632543" y="3485691"/>
+            <a:off x="3564431" y="3485691"/>
             <a:ext cx="1176480" cy="198000"/>
           </a:xfrm>
           <a:prstGeom prst="rect">
@@ -34984,7 +34984,7 @@
         <p:spPr>
           <a:xfrm>
             <a:off x="687600" y="3723291"/>
-            <a:ext cx="1839023" cy="198000"/>
+            <a:ext cx="1770912" cy="198000"/>
           </a:xfrm>
           <a:prstGeom prst="rect">
             <a:avLst/>
@@ -35022,7 +35022,7 @@
         </p:nvSpPr>
         <p:spPr>
           <a:xfrm>
-            <a:off x="2584224" y="3723291"/>
+            <a:off x="2516112" y="3723291"/>
             <a:ext cx="990719" cy="198000"/>
           </a:xfrm>
           <a:prstGeom prst="rect">
@@ -35061,7 +35061,7 @@
         </p:nvSpPr>
         <p:spPr>
           <a:xfrm>
-            <a:off x="3632543" y="3723291"/>
+            <a:off x="3564431" y="3723291"/>
             <a:ext cx="1176480" cy="198000"/>
           </a:xfrm>
           <a:prstGeom prst="rect">
@@ -35140,7 +35140,7 @@
         <p:spPr>
           <a:xfrm>
             <a:off x="687600" y="3960891"/>
-            <a:ext cx="1839023" cy="198000"/>
+            <a:ext cx="1770912" cy="198000"/>
           </a:xfrm>
           <a:prstGeom prst="rect">
             <a:avLst/>
@@ -35178,7 +35178,7 @@
         </p:nvSpPr>
         <p:spPr>
           <a:xfrm>
-            <a:off x="2584224" y="3960891"/>
+            <a:off x="2516112" y="3960891"/>
             <a:ext cx="990719" cy="198000"/>
           </a:xfrm>
           <a:prstGeom prst="rect">
@@ -35217,7 +35217,7 @@
         </p:nvSpPr>
         <p:spPr>
           <a:xfrm>
-            <a:off x="3632543" y="3960891"/>
+            <a:off x="3564431" y="3960891"/>
             <a:ext cx="1176480" cy="198000"/>
           </a:xfrm>
           <a:prstGeom prst="rect">
@@ -35296,7 +35296,7 @@
         <p:spPr>
           <a:xfrm>
             <a:off x="687600" y="4198491"/>
-            <a:ext cx="1839023" cy="198000"/>
+            <a:ext cx="1770912" cy="198000"/>
           </a:xfrm>
           <a:prstGeom prst="rect">
             <a:avLst/>
@@ -35334,7 +35334,7 @@
         </p:nvSpPr>
         <p:spPr>
           <a:xfrm>
-            <a:off x="2584224" y="4198491"/>
+            <a:off x="2516112" y="4198491"/>
             <a:ext cx="990719" cy="198000"/>
           </a:xfrm>
           <a:prstGeom prst="rect">
@@ -35373,7 +35373,7 @@
         </p:nvSpPr>
         <p:spPr>
           <a:xfrm>
-            <a:off x="3632543" y="4198491"/>
+            <a:off x="3564431" y="4198491"/>
             <a:ext cx="1176480" cy="198000"/>
           </a:xfrm>
           <a:prstGeom prst="rect">
@@ -35452,7 +35452,7 @@
         <p:spPr>
           <a:xfrm>
             <a:off x="687600" y="4436091"/>
-            <a:ext cx="1839023" cy="198000"/>
+            <a:ext cx="1770912" cy="198000"/>
           </a:xfrm>
           <a:prstGeom prst="rect">
             <a:avLst/>
@@ -35490,7 +35490,7 @@
         </p:nvSpPr>
         <p:spPr>
           <a:xfrm>
-            <a:off x="2584224" y="4436091"/>
+            <a:off x="2516112" y="4436091"/>
             <a:ext cx="990719" cy="198000"/>
           </a:xfrm>
           <a:prstGeom prst="rect">
@@ -35529,7 +35529,7 @@
         </p:nvSpPr>
         <p:spPr>
           <a:xfrm>
-            <a:off x="3632543" y="4436091"/>
+            <a:off x="3564431" y="4436091"/>
             <a:ext cx="1176480" cy="198000"/>
           </a:xfrm>
           <a:prstGeom prst="rect">
@@ -35608,7 +35608,7 @@
         <p:spPr>
           <a:xfrm>
             <a:off x="687600" y="4673691"/>
-            <a:ext cx="1839023" cy="198000"/>
+            <a:ext cx="1770912" cy="198000"/>
           </a:xfrm>
           <a:prstGeom prst="rect">
             <a:avLst/>
@@ -35646,7 +35646,7 @@
         </p:nvSpPr>
         <p:spPr>
           <a:xfrm>
-            <a:off x="2584224" y="4673691"/>
+            <a:off x="2516112" y="4673691"/>
             <a:ext cx="990719" cy="198000"/>
           </a:xfrm>
           <a:prstGeom prst="rect">
@@ -35685,7 +35685,7 @@
         </p:nvSpPr>
         <p:spPr>
           <a:xfrm>
-            <a:off x="3632543" y="4673691"/>
+            <a:off x="3564431" y="4673691"/>
             <a:ext cx="1176480" cy="198000"/>
           </a:xfrm>
           <a:prstGeom prst="rect">
@@ -35764,7 +35764,7 @@
         <p:spPr>
           <a:xfrm>
             <a:off x="687600" y="4911291"/>
-            <a:ext cx="1839023" cy="198000"/>
+            <a:ext cx="1770912" cy="198000"/>
           </a:xfrm>
           <a:prstGeom prst="rect">
             <a:avLst/>
@@ -35789,7 +35789,7 @@
                 </a:solidFill>
                 <a:latin typeface="Barlow"/>
               </a:rPr>
-              <a:t>Vidéo TESTY — libre service</a:t>
+              <a:t>Mini-Série TESTY</a:t>
             </a:r>
           </a:p>
         </p:txBody>
@@ -35802,7 +35802,7 @@
         </p:nvSpPr>
         <p:spPr>
           <a:xfrm>
-            <a:off x="2584224" y="4911291"/>
+            <a:off x="2516112" y="4911291"/>
             <a:ext cx="990719" cy="198000"/>
           </a:xfrm>
           <a:prstGeom prst="rect">
@@ -35841,7 +35841,7 @@
         </p:nvSpPr>
         <p:spPr>
           <a:xfrm>
-            <a:off x="3632543" y="4911291"/>
+            <a:off x="3564431" y="4911291"/>
             <a:ext cx="1176480" cy="198000"/>
           </a:xfrm>
           <a:prstGeom prst="rect">

</xml_diff>

<commit_message>
fix(programme): Erwan PERIGAULT est USR, pas SDSI
Cinq endroits, dont la page servie et les deux cartes de scène qui nomment la
table ronde. « SDSI » reste ailleurs : c'est le nom du kiosque 7, sans rapport.

Co-Authored-By: Claude Opus 5 <noreply@anthropic.com>
Claude-Session: https://claude.ai/code/session_01Pwjz3VzeEknRuHTVSBE4Pa
</commit_message>
<xml_diff>
--- a/outils/fiches/fiches-animateurs.pptx
+++ b/outils/fiches/fiches-animateurs.pptx
@@ -15970,7 +15970,7 @@
                 </a:solidFill>
                 <a:latin typeface="Barlow"/>
               </a:rPr>
-              <a:t>Avec toi : Grégory BARRANCO (TMV) et Erwan PERIGAULT (SDSI).</a:t>
+              <a:t>Avec toi : Grégory BARRANCO (TMV) et Erwan PERIGAULT (USR).</a:t>
             </a:r>
           </a:p>
         </p:txBody>
@@ -30785,7 +30785,7 @@
                 </a:solidFill>
                 <a:latin typeface="Barlow"/>
               </a:rPr>
-              <a:t>Table ronde — Mode produit et les tests. Ghislaine DOPIERRE (TFC), Grégory BARRANCO (TMV), Erwan PERIGAULT (SDSI), animée par Fabrice CHATRON. Remercie les intervenants.</a:t>
+              <a:t>Table ronde — Mode produit et les tests. Ghislaine DOPIERRE (TFC), Grégory BARRANCO (TMV), Erwan PERIGAULT (USR), animée par Fabrice CHATRON. Remercie les intervenants.</a:t>
             </a:r>
           </a:p>
         </p:txBody>

</xml_diff>

<commit_message>
fix(programme): « DF Dommages » avec un s, kiosques 7 et 9
L'entité s'écrit au pluriel. Deux occurrences dans la page servie — Vamé
SYLLA au kiosque 7, Aurore CAPLAN au kiosque 9 — et la question 14 du
conducteur, qui citait l'ancienne écriture.

Les cartes de scène sont régénérées : elles relisent les porteurs dans la
page, l'orthographe n'est écrite qu'à un seul endroit.

Co-Authored-By: Claude Opus 5 <noreply@anthropic.com>
Claude-Session: https://claude.ai/code/session_01Pwjz3VzeEknRuHTVSBE4Pa
</commit_message>
<xml_diff>
--- a/outils/fiches/fiches-animateurs.pptx
+++ b/outils/fiches/fiches-animateurs.pptx
@@ -5221,7 +5221,7 @@
                 </a:solidFill>
                 <a:latin typeface="Barlow"/>
               </a:rPr>
-              <a:t>Porté par TFC · Vincent TREVARIN / DF Dommage · Aurore CAPLAN.</a:t>
+              <a:t>Porté par TFC · Vincent TREVARIN / DF Dommages · Aurore CAPLAN.</a:t>
             </a:r>
           </a:p>
         </p:txBody>
@@ -10807,7 +10807,7 @@
                 </a:solidFill>
                 <a:latin typeface="Barlow"/>
               </a:rPr>
-              <a:t>Porté par TFC · Vincent TREVARIN / DF Dommage · Aurore CAPLAN.</a:t>
+              <a:t>Porté par TFC · Vincent TREVARIN / DF Dommages · Aurore CAPLAN.</a:t>
             </a:r>
           </a:p>
         </p:txBody>
@@ -24539,7 +24539,7 @@
                 </a:solidFill>
                 <a:latin typeface="Barlow"/>
               </a:rPr>
-              <a:t>TFC · DF Dommage</a:t>
+              <a:t>TFC · DF Dommages</a:t>
             </a:r>
           </a:p>
         </p:txBody>
@@ -25319,7 +25319,7 @@
                 </a:solidFill>
                 <a:latin typeface="Barlow"/>
               </a:rPr>
-              <a:t>TFC · DF Dommage</a:t>
+              <a:t>TFC · DF Dommages</a:t>
             </a:r>
           </a:p>
         </p:txBody>
@@ -27439,7 +27439,7 @@
                 </a:solidFill>
                 <a:latin typeface="Barlow"/>
               </a:rPr>
-              <a:t>Porté par TFC · Donatien REVEAU et Elodie TORDJMAN / DF Dommage · Vamé SYLLA.</a:t>
+              <a:t>Porté par TFC · Donatien REVEAU et Elodie TORDJMAN / DF Dommages · Vamé SYLLA.</a:t>
             </a:r>
           </a:p>
         </p:txBody>
@@ -29364,7 +29364,7 @@
                 </a:solidFill>
                 <a:latin typeface="Barlow"/>
               </a:rPr>
-              <a:t>Porté par TFC · Donatien REVEAU et Elodie TORDJMAN / DF Dommage · Vamé SYLLA.</a:t>
+              <a:t>Porté par TFC · Donatien REVEAU et Elodie TORDJMAN / DF Dommages · Vamé SYLLA.</a:t>
             </a:r>
           </a:p>
         </p:txBody>
@@ -38624,7 +38624,7 @@
                 </a:solidFill>
                 <a:latin typeface="Barlow"/>
               </a:rPr>
-              <a:t>TFC · DF Dommage</a:t>
+              <a:t>TFC · DF Dommages</a:t>
             </a:r>
           </a:p>
         </p:txBody>
@@ -39404,7 +39404,7 @@
                 </a:solidFill>
                 <a:latin typeface="Barlow"/>
               </a:rPr>
-              <a:t>TFC · DF Dommage</a:t>
+              <a:t>TFC · DF Dommages</a:t>
             </a:r>
           </a:p>
         </p:txBody>

</xml_diff>